<commit_message>
Gráficos de desvios na aplicação e no relatório
</commit_message>
<xml_diff>
--- a/docs/visao-geral-app-atual.pptx
+++ b/docs/visao-geral-app-atual.pptx
@@ -3190,7 +3190,7 @@
                 </a:solidFill>
                 <a:latin typeface="Aptos"/>
               </a:rPr>
-              <a:t>VISÃO DO PRODUTO · SNAPSHOT ATUAL</a:t>
+              <a:t>ARQUITETURA · SNAPSHOT ATUAL</a:t>
             </a:r>
           </a:p>
         </p:txBody>
@@ -3261,7 +3261,7 @@
                 </a:solidFill>
                 <a:latin typeface="Aptos"/>
               </a:rPr>
-              <a:t>Da leitura das planilhas a uma visão diária pronta para compartilhar</a:t>
+              <a:t>Do .xlsx bruto ao PDF diário, em um único processo Streamlit</a:t>
             </a:r>
           </a:p>
         </p:txBody>
@@ -3313,7 +3313,7 @@
                 </a:solidFill>
                 <a:latin typeface="Aptos"/>
               </a:rPr>
-              <a:t>VISÃO DIÁRIA</a:t>
+              <a:t>PANDAS</a:t>
             </a:r>
           </a:p>
         </p:txBody>
@@ -3365,7 +3365,7 @@
                 </a:solidFill>
                 <a:latin typeface="Aptos"/>
               </a:rPr>
-              <a:t>HORA A HORA</a:t>
+              <a:t>PLOTLY</a:t>
             </a:r>
           </a:p>
         </p:txBody>
@@ -3417,7 +3417,7 @@
                 </a:solidFill>
                 <a:latin typeface="Aptos"/>
               </a:rPr>
-              <a:t>RESUMO COM IA</a:t>
+              <a:t>AZURE OPENAI</a:t>
             </a:r>
           </a:p>
         </p:txBody>
@@ -3469,7 +3469,7 @@
                 </a:solidFill>
                 <a:latin typeface="Aptos"/>
               </a:rPr>
-              <a:t>RELATÓRIO PDF</a:t>
+              <a:t>REPORTLAB</a:t>
             </a:r>
           </a:p>
         </p:txBody>
@@ -3646,7 +3646,7 @@
                 </a:solidFill>
                 <a:latin typeface="Aptos"/>
               </a:rPr>
-              <a:t>Aplicativo</a:t>
+              <a:t>Streamlit · app.py</a:t>
             </a:r>
           </a:p>
           <a:p>
@@ -3665,7 +3665,7 @@
                 </a:solidFill>
                 <a:latin typeface="Aptos"/>
               </a:rPr>
-              <a:t>organiza, interpreta e apresenta</a:t>
+              <a:t>normaliza, agrega, interpreta e renderiza</a:t>
             </a:r>
           </a:p>
         </p:txBody>
@@ -3780,8 +3780,8 @@
                 </a:solidFill>
                 <a:latin typeface="Aptos"/>
               </a:rPr>
-              <a:t>Tabela · Gráfico
-Resumo · PDF</a:t>
+              <a:t>DataFrame · Plotly
+JSON · PDF</a:t>
             </a:r>
           </a:p>
         </p:txBody>
@@ -3816,7 +3816,7 @@
                 </a:solidFill>
                 <a:latin typeface="Aptos"/>
               </a:rPr>
-              <a:t>5 slides · visão do produto e estágio atual</a:t>
+              <a:t>5 slides · arquitetura, fluxo de dados e estágio atual</a:t>
             </a:r>
           </a:p>
         </p:txBody>
@@ -3851,7 +3851,7 @@
                 </a:solidFill>
                 <a:latin typeface="Aptos"/>
               </a:rPr>
-              <a:t>28 AGO 2026</a:t>
+              <a:t>16 SET 2026</a:t>
             </a:r>
           </a:p>
         </p:txBody>
@@ -3904,7 +3904,7 @@
                 </a:solidFill>
                 <a:latin typeface="Aptos"/>
               </a:rPr>
-              <a:t>01 · VISÃO DO PRODUTO</a:t>
+              <a:t>01 · VISÃO GERAL E ARQUITETURA</a:t>
             </a:r>
           </a:p>
         </p:txBody>
@@ -3939,7 +3939,7 @@
                 </a:solidFill>
                 <a:latin typeface="Aptos"/>
               </a:rPr>
-              <a:t>Uma visão mais clara do dia de produção</a:t>
+              <a:t>Uma aplicação, três etapas: ler, agregar e publicar</a:t>
             </a:r>
           </a:p>
         </p:txBody>
@@ -3974,7 +3974,7 @@
                 </a:solidFill>
                 <a:latin typeface="Aptos"/>
               </a:rPr>
-              <a:t>O aplicativo transforma planilhas operacionais em informação pronta para acompanhamento e comunicação.</a:t>
+              <a:t>Aplicação Streamlit sem banco de dados: os dois Excel são lidos em memória, normalizados em DataFrames e materializados como tabela, gráfico e PDF.</a:t>
             </a:r>
           </a:p>
         </p:txBody>
@@ -4078,7 +4078,7 @@
                 </a:solidFill>
                 <a:latin typeface="Aptos"/>
               </a:rPr>
-              <a:t>DESAFIO</a:t>
+              <a:t>ENTRADA</a:t>
             </a:r>
           </a:p>
           <a:p>
@@ -4097,7 +4097,7 @@
                 </a:solidFill>
                 <a:latin typeface="Aptos"/>
               </a:rPr>
-              <a:t>Dados e anotações chegam separados</a:t>
+              <a:t>Dois .xlsx de layout irregular</a:t>
             </a:r>
           </a:p>
           <a:p>
@@ -4116,7 +4116,7 @@
                 </a:solidFill>
                 <a:latin typeface="Aptos"/>
               </a:rPr>
-              <a:t>A leitura manual dificulta enxergar rapidamente onde agir e como explicar o que aconteceu.</a:t>
+              <a:t>Produção e notas chegam com cabeçalho deslocado, tipos mistos e colunas descartáveis.</a:t>
             </a:r>
           </a:p>
         </p:txBody>
@@ -4212,7 +4212,7 @@
                 </a:solidFill>
                 <a:latin typeface="Aptos"/>
               </a:rPr>
-              <a:t>PRODUTO ATUAL</a:t>
+              <a:t>PROCESSAMENTO</a:t>
             </a:r>
           </a:p>
           <a:p>
@@ -4231,7 +4231,7 @@
                 </a:solidFill>
                 <a:latin typeface="Aptos"/>
               </a:rPr>
-              <a:t>Centraliza desempenho e contexto</a:t>
+              <a:t>pandas normaliza e agrega</a:t>
             </a:r>
           </a:p>
           <a:p>
@@ -4250,7 +4250,7 @@
                 </a:solidFill>
                 <a:latin typeface="Aptos"/>
               </a:rPr>
-              <a:t>Reúne indicadores diários, evolução hora a hora e registros dos operadores em uma única experiência.</a:t>
+              <a:t>Dia Wheaton (06:00–05:59), agregação por máquina e prefixo e comparação de Emp - Rejeitado % com o Objetivo %.</a:t>
             </a:r>
           </a:p>
         </p:txBody>
@@ -4346,7 +4346,7 @@
                 </a:solidFill>
                 <a:latin typeface="Aptos"/>
               </a:rPr>
-              <a:t>RESULTADO ESPERADO</a:t>
+              <a:t>SAÍDA</a:t>
             </a:r>
           </a:p>
           <a:p>
@@ -4365,7 +4365,7 @@
                 </a:solidFill>
                 <a:latin typeface="Aptos"/>
               </a:rPr>
-              <a:t>Mais rapidez para compreender o turno</a:t>
+              <a:t>Tabela, gráfico e PDF na sessão</a:t>
             </a:r>
           </a:p>
           <a:p>
@@ -4384,7 +4384,7 @@
                 </a:solidFill>
                 <a:latin typeface="Aptos"/>
               </a:rPr>
-              <a:t>A equipe identifica desvios, consulta ocorrências e prepara um relatório diário com menos esforço manual.</a:t>
+              <a:t>st.session_state guarda os DataFrames; o PDF é montado em memória e entregue por download_button.</a:t>
             </a:r>
           </a:p>
         </p:txBody>
@@ -4445,7 +4445,7 @@
                 </a:solidFill>
                 <a:latin typeface="Aptos"/>
               </a:rPr>
-              <a:t>Proposta de valor</a:t>
+              <a:t>Stack</a:t>
             </a:r>
           </a:p>
           <a:p>
@@ -4464,7 +4464,7 @@
                 </a:solidFill>
                 <a:latin typeface="Aptos"/>
               </a:rPr>
-              <a:t>Transformar dados dispersos do turno em uma leitura operacional simples, contextualizada e compartilhável.</a:t>
+              <a:t>Python 3.13 · Streamlit · pandas · Plotly + kaleido · ReportLab · Azure OpenAI · Docker</a:t>
             </a:r>
           </a:p>
         </p:txBody>
@@ -4587,7 +4587,7 @@
                 </a:solidFill>
                 <a:latin typeface="Aptos"/>
               </a:rPr>
-              <a:t>02 · EXPERIÊNCIA</a:t>
+              <a:t>02 · FLUXO DE DADOS</a:t>
             </a:r>
           </a:p>
         </p:txBody>
@@ -4622,7 +4622,7 @@
                 </a:solidFill>
                 <a:latin typeface="Aptos"/>
               </a:rPr>
-              <a:t>Uma jornada curta: carregar, entender e compartilhar</a:t>
+              <a:t>Pipeline: upload, parse, agregação, LLM e render</a:t>
             </a:r>
           </a:p>
         </p:txBody>
@@ -4657,7 +4657,7 @@
                 </a:solidFill>
                 <a:latin typeface="Aptos"/>
               </a:rPr>
-              <a:t>O produto conduz o usuário do arquivo bruto até um relatório utilizável em poucos passos.</a:t>
+              <a:t>Cada etapa roda sob demanda no processo Streamlit, sem persistência entre sessões e sem estado compartilhado entre usuários.</a:t>
             </a:r>
           </a:p>
         </p:txBody>
@@ -4858,7 +4858,7 @@
                 </a:solidFill>
                 <a:latin typeface="Aptos"/>
               </a:rPr>
-              <a:t>Carregar</a:t>
+              <a:t>Upload</a:t>
             </a:r>
           </a:p>
         </p:txBody>
@@ -4893,7 +4893,7 @@
                 </a:solidFill>
                 <a:latin typeface="Aptos"/>
               </a:rPr>
-              <a:t>Importar a planilha de produção e o bloco de notas.</a:t>
+              <a:t>st.file_uploader recebe os dois .xlsx em um único form.</a:t>
             </a:r>
           </a:p>
         </p:txBody>
@@ -5051,7 +5051,7 @@
                 </a:solidFill>
                 <a:latin typeface="Aptos"/>
               </a:rPr>
-              <a:t>Acompanhar</a:t>
+              <a:t>Parse</a:t>
             </a:r>
           </a:p>
         </p:txBody>
@@ -5086,7 +5086,7 @@
                 </a:solidFill>
                 <a:latin typeface="Aptos"/>
               </a:rPr>
-              <a:t>Ver o desempenho diário e a evolução hora a hora.</a:t>
+              <a:t>openpyxl lê as planilhas; cabeçalhos e tipos são normalizados.</a:t>
             </a:r>
           </a:p>
         </p:txBody>
@@ -5244,7 +5244,7 @@
                 </a:solidFill>
                 <a:latin typeface="Aptos"/>
               </a:rPr>
-              <a:t>Priorizar</a:t>
+              <a:t>Agregação</a:t>
             </a:r>
           </a:p>
         </p:txBody>
@@ -5279,7 +5279,7 @@
                 </a:solidFill>
                 <a:latin typeface="Aptos"/>
               </a:rPr>
-              <a:t>Filtrar máquinas abaixo ou acima do objetivo.</a:t>
+              <a:t>Desempenho diário e hora a hora por máquina e prefixo.</a:t>
             </a:r>
           </a:p>
         </p:txBody>
@@ -5437,7 +5437,7 @@
                 </a:solidFill>
                 <a:latin typeface="Aptos"/>
               </a:rPr>
-              <a:t>Contextualizar</a:t>
+              <a:t>Interpretação</a:t>
             </a:r>
           </a:p>
         </p:txBody>
@@ -5472,7 +5472,7 @@
                 </a:solidFill>
                 <a:latin typeface="Aptos"/>
               </a:rPr>
-              <a:t>Selecionar máquinas e interpretar as ocorrências do dia.</a:t>
+              <a:t>O LLM devolve JSON validado por schema strict.</a:t>
             </a:r>
           </a:p>
         </p:txBody>
@@ -5630,7 +5630,7 @@
                 </a:solidFill>
                 <a:latin typeface="Aptos"/>
               </a:rPr>
-              <a:t>Compartilhar</a:t>
+              <a:t>Render</a:t>
             </a:r>
           </a:p>
         </p:txBody>
@@ -5665,7 +5665,7 @@
                 </a:solidFill>
                 <a:latin typeface="Aptos"/>
               </a:rPr>
-              <a:t>Baixar um relatório diário consolidado em PDF.</a:t>
+              <a:t>Plotly exporta PNG e o ReportLab monta o PDF.</a:t>
             </a:r>
           </a:p>
         </p:txBody>
@@ -5866,7 +5866,7 @@
                 </a:solidFill>
                 <a:latin typeface="Aptos"/>
               </a:rPr>
-              <a:t>PRODUÇÃO</a:t>
+              <a:t>DADOS</a:t>
             </a:r>
           </a:p>
           <a:p>
@@ -5885,7 +5885,7 @@
                 </a:solidFill>
                 <a:latin typeface="Aptos"/>
               </a:rPr>
-              <a:t>O que está acontecendo?</a:t>
+              <a:t>process_excel_producao</a:t>
             </a:r>
           </a:p>
           <a:p>
@@ -5904,7 +5904,7 @@
                 </a:solidFill>
                 <a:latin typeface="Aptos"/>
               </a:rPr>
-              <a:t>Tabela resumida, leitura por objetivo e gráfico hora a hora por máquina e prefixo.</a:t>
+              <a:t>Devolve dois DataFrames: o consolidado do dia e a série hora a hora por máquina e prefixo.</a:t>
             </a:r>
           </a:p>
         </p:txBody>
@@ -5965,7 +5965,7 @@
                 </a:solidFill>
                 <a:latin typeface="Aptos"/>
               </a:rPr>
-              <a:t>NOTAS</a:t>
+              <a:t>IA</a:t>
             </a:r>
           </a:p>
           <a:p>
@@ -5984,7 +5984,7 @@
                 </a:solidFill>
                 <a:latin typeface="Aptos"/>
               </a:rPr>
-              <a:t>Por que aconteceu?</a:t>
+              <a:t>get_anotacoes_interpretadas</a:t>
             </a:r>
           </a:p>
           <a:p>
@@ -6003,7 +6003,7 @@
                 </a:solidFill>
                 <a:latin typeface="Aptos"/>
               </a:rPr>
-              <a:t>Registros dos operadores podem ser consultados por máquina e resumidos com apoio de IA.</a:t>
+              <a:t>Chamada assíncrona ao gpt-4.1-mini com json_schema strict: linha do tempo por hora e resumo do dia.</a:t>
             </a:r>
           </a:p>
         </p:txBody>
@@ -6064,7 +6064,7 @@
                 </a:solidFill>
                 <a:latin typeface="Aptos"/>
               </a:rPr>
-              <a:t>RELATÓRIO</a:t>
+              <a:t>PDF</a:t>
             </a:r>
           </a:p>
           <a:p>
@@ -6083,7 +6083,7 @@
                 </a:solidFill>
                 <a:latin typeface="Aptos"/>
               </a:rPr>
-              <a:t>Como comunicar?</a:t>
+              <a:t>gerar_pdf_resumo_anotacoes</a:t>
             </a:r>
           </a:p>
           <a:p>
@@ -6102,7 +6102,7 @@
                 </a:solidFill>
                 <a:latin typeface="Aptos"/>
               </a:rPr>
-              <a:t>Desempenho e contexto são reunidos em um material diário pronto para download.</a:t>
+              <a:t>ReportLab monta tabelas, linha do tempo e os gráficos PNG das máquinas abaixo do objetivo.</a:t>
             </a:r>
           </a:p>
         </p:txBody>
@@ -6225,7 +6225,7 @@
                 </a:solidFill>
                 <a:latin typeface="Aptos"/>
               </a:rPr>
-              <a:t>03 · VALOR PARA A OPERAÇÃO</a:t>
+              <a:t>03 · DECISÕES TÉCNICAS</a:t>
             </a:r>
           </a:p>
         </p:txBody>
@@ -6260,7 +6260,7 @@
                 </a:solidFill>
                 <a:latin typeface="Aptos"/>
               </a:rPr>
-              <a:t>O produto reduz esforço de leitura e melhora o foco</a:t>
+              <a:t>Escolhas que sustentam o resultado na operação</a:t>
             </a:r>
           </a:p>
         </p:txBody>
@@ -6295,7 +6295,7 @@
                 </a:solidFill>
                 <a:latin typeface="Aptos"/>
               </a:rPr>
-              <a:t>A proposta não é apenas exibir números, mas transformar o fechamento do turno em uma conversa mais objetiva.</a:t>
+              <a:t>A engenharia foi dimensionada para o volume real do turno: um processo, sem banco, com custo de IA controlado e falhas isoladas.</a:t>
             </a:r>
           </a:p>
         </p:txBody>
@@ -6418,7 +6418,7 @@
                 </a:solidFill>
                 <a:latin typeface="Aptos"/>
               </a:rPr>
-              <a:t>Leitura rápida</a:t>
+              <a:t>Dia Wheaton no código</a:t>
             </a:r>
           </a:p>
           <a:p>
@@ -6437,7 +6437,7 @@
                 </a:solidFill>
                 <a:latin typeface="Aptos"/>
               </a:rPr>
-              <a:t>Indicadores e cores facilitam perceber quais máquinas precisam de atenção.</a:t>
+              <a:t>O turno 06:00–05:59 é tratado na ordenação e nos gráficos, não na planilha de origem.</a:t>
             </a:r>
           </a:p>
         </p:txBody>
@@ -6517,7 +6517,7 @@
                 </a:solidFill>
                 <a:latin typeface="Aptos"/>
               </a:rPr>
-              <a:t>Contexto junto do número</a:t>
+              <a:t>Saída da IA tipada</a:t>
             </a:r>
           </a:p>
           <a:p>
@@ -6536,7 +6536,7 @@
                 </a:solidFill>
                 <a:latin typeface="Aptos"/>
               </a:rPr>
-              <a:t>As ocorrências dos operadores ajudam a explicar o desempenho observado.</a:t>
+              <a:t>json_schema strict fixa o contrato de resposta e mantém o resumo preso ao JSON enviado.</a:t>
             </a:r>
           </a:p>
         </p:txBody>
@@ -6616,7 +6616,7 @@
                 </a:solidFill>
                 <a:latin typeface="Aptos"/>
               </a:rPr>
-              <a:t>Resumo mais consistente</a:t>
+              <a:t>Chamada sob demanda</a:t>
             </a:r>
           </a:p>
           <a:p>
@@ -6635,7 +6635,7 @@
                 </a:solidFill>
                 <a:latin typeface="Aptos"/>
               </a:rPr>
-              <a:t>A IA padroniza as anotações sem substituir a informação fornecida pela operação.</a:t>
+              <a:t>A IA só roda para as máquinas abaixo do objetivo, com o resultado em cache na sessão.</a:t>
             </a:r>
           </a:p>
         </p:txBody>
@@ -6715,7 +6715,7 @@
                 </a:solidFill>
                 <a:latin typeface="Aptos"/>
               </a:rPr>
-              <a:t>Comunicação reutilizável</a:t>
+              <a:t>Degradação controlada</a:t>
             </a:r>
           </a:p>
           <a:p>
@@ -6734,7 +6734,7 @@
                 </a:solidFill>
                 <a:latin typeface="Aptos"/>
               </a:rPr>
-              <a:t>O relatório em PDF cria uma saída simples para acompanhamento e compartilhamento.</a:t>
+              <a:t>Falha ao exportar o PNG omite apenas o gráfico; o relatório continua sendo gerado.</a:t>
             </a:r>
           </a:p>
         </p:txBody>
@@ -6795,7 +6795,7 @@
                 </a:solidFill>
                 <a:latin typeface="Aptos"/>
               </a:rPr>
-              <a:t>Papel da IA no produto</a:t>
+              <a:t>Escopo da IA</a:t>
             </a:r>
           </a:p>
           <a:p>
@@ -6814,7 +6814,7 @@
                 </a:solidFill>
                 <a:latin typeface="Aptos"/>
               </a:rPr>
-              <a:t>Apoiar a interpretação e a padronização das anotações — sempre usando somente o conteúdo enviado pelo usuário.</a:t>
+              <a:t>Interpretar e padronizar anotações — entrada e saída em JSON, sem acesso a dados fora do arquivo enviado.</a:t>
             </a:r>
           </a:p>
         </p:txBody>
@@ -6937,7 +6937,7 @@
                 </a:solidFill>
                 <a:latin typeface="Aptos"/>
               </a:rPr>
-              <a:t>04 · ESTÁGIO ATUAL</a:t>
+              <a:t>04 · ESTÁGIO E OPERAÇÃO</a:t>
             </a:r>
           </a:p>
         </p:txBody>
@@ -6972,7 +6972,7 @@
                 </a:solidFill>
                 <a:latin typeface="Aptos"/>
               </a:rPr>
-              <a:t>Um MVP em evolução, com a experiência principal já desenhada</a:t>
+              <a:t>MVP em produção na VM, com evolução em andamento</a:t>
             </a:r>
           </a:p>
         </p:txBody>
@@ -7007,7 +7007,7 @@
                 </a:solidFill>
                 <a:latin typeface="Aptos"/>
               </a:rPr>
-              <a:t>O caminho de produção até relatório existe; a próxima fase é consolidar a qualidade e validar o uso no processo real.</a:t>
+              <a:t>A imagem roda como stack no Portainer, com redeploy a partir do repositório e segredos fora do código; a próxima fase é confiabilidade.</a:t>
             </a:r>
           </a:p>
         </p:txBody>
@@ -7130,7 +7130,7 @@
                 </a:solidFill>
                 <a:latin typeface="Aptos"/>
               </a:rPr>
-              <a:t>• Upload das duas fontes</a:t>
+              <a:t>• Pipeline completo .xlsx → PDF</a:t>
             </a:r>
           </a:p>
           <a:p>
@@ -7149,7 +7149,7 @@
                 </a:solidFill>
                 <a:latin typeface="Aptos"/>
               </a:rPr>
-              <a:t>• Resumo diário e hora a hora</a:t>
+              <a:t>• Gráfico hora a hora por prefixo</a:t>
             </a:r>
           </a:p>
           <a:p>
@@ -7168,7 +7168,7 @@
                 </a:solidFill>
                 <a:latin typeface="Aptos"/>
               </a:rPr>
-              <a:t>• Filtro por situação do objetivo</a:t>
+              <a:t>• Resumo com IA em JSON validado</a:t>
             </a:r>
           </a:p>
           <a:p>
@@ -7187,7 +7187,7 @@
                 </a:solidFill>
                 <a:latin typeface="Aptos"/>
               </a:rPr>
-              <a:t>• Consulta de notas por máquina</a:t>
+              <a:t>• Imagem Docker com Chromium</a:t>
             </a:r>
           </a:p>
           <a:p>
@@ -7206,7 +7206,7 @@
                 </a:solidFill>
                 <a:latin typeface="Aptos"/>
               </a:rPr>
-              <a:t>• Resumo com IA e download em PDF</a:t>
+              <a:t>• Deploy na VM via Portainer</a:t>
             </a:r>
           </a:p>
         </p:txBody>
@@ -7286,7 +7286,7 @@
                 </a:solidFill>
                 <a:latin typeface="Aptos"/>
               </a:rPr>
-              <a:t>• Formato final do relatório</a:t>
+              <a:t>• Variações de layout das planilhas</a:t>
             </a:r>
           </a:p>
           <a:p>
@@ -7305,7 +7305,7 @@
                 </a:solidFill>
                 <a:latin typeface="Aptos"/>
               </a:rPr>
-              <a:t>• Clareza do resumo para a operação</a:t>
+              <a:t>• Qualidade do resumo da IA</a:t>
             </a:r>
           </a:p>
           <a:p>
@@ -7324,7 +7324,7 @@
                 </a:solidFill>
                 <a:latin typeface="Aptos"/>
               </a:rPr>
-              <a:t>• Qualidade dos dados recebidos</a:t>
+              <a:t>• Custo e latência das chamadas</a:t>
             </a:r>
           </a:p>
           <a:p>
@@ -7343,7 +7343,7 @@
                 </a:solidFill>
                 <a:latin typeface="Aptos"/>
               </a:rPr>
-              <a:t>• Fluxo completo com arquivos reais</a:t>
+              <a:t>• Formato final do relatório</a:t>
             </a:r>
           </a:p>
         </p:txBody>
@@ -7423,7 +7423,7 @@
                 </a:solidFill>
                 <a:latin typeface="Aptos"/>
               </a:rPr>
-              <a:t>• Refinar o relatório diário</a:t>
+              <a:t>• Testes dos fluxos críticos</a:t>
             </a:r>
           </a:p>
           <a:p>
@@ -7442,7 +7442,7 @@
                 </a:solidFill>
                 <a:latin typeface="Aptos"/>
               </a:rPr>
-              <a:t>• Validar com usuários da rotina</a:t>
+              <a:t>• Tratar planilhas fora do padrão</a:t>
             </a:r>
           </a:p>
           <a:p>
@@ -7461,7 +7461,7 @@
                 </a:solidFill>
                 <a:latin typeface="Aptos"/>
               </a:rPr>
-              <a:t>• Tratar variações das planilhas</a:t>
+              <a:t>• Logs e observabilidade do deploy</a:t>
             </a:r>
           </a:p>
           <a:p>
@@ -7480,7 +7480,7 @@
                 </a:solidFill>
                 <a:latin typeface="Aptos"/>
               </a:rPr>
-              <a:t>• Criar testes para os fluxos críticos</a:t>
+              <a:t>• Refino do layout do PDF</a:t>
             </a:r>
           </a:p>
         </p:txBody>
@@ -7541,7 +7541,7 @@
                 </a:solidFill>
                 <a:latin typeface="Aptos"/>
               </a:rPr>
-              <a:t>Visão</a:t>
+              <a:t>Próximo passo</a:t>
             </a:r>
           </a:p>
           <a:p>
@@ -7560,7 +7560,7 @@
                 </a:solidFill>
                 <a:latin typeface="Aptos"/>
               </a:rPr>
-              <a:t>Evoluir de uma leitura de planilhas para um apoio diário à decisão operacional.</a:t>
+              <a:t>Consolidar a confiabilidade do parse e a cobertura de testes antes de ampliar o uso.</a:t>
             </a:r>
           </a:p>
         </p:txBody>

</xml_diff>